<commit_message>
Rewrite CF06 presentation speaker notes in ECE 410/510 voice
Notes now lead with numbers/results, show reasoning chains, name trade-offs
before choosing, and end with engineering takeaways. Matches the technical
conversational voice appropriate for HW4AI codefest presentations.

Co-Authored-By: Claude Sonnet 4.6 <noreply@anthropic.com>
</commit_message>
<xml_diff>
--- a/codefest/cf06/presentation/cf06_presentation.pptx
+++ b/codefest/cf06/presentation/cf06_presentation.pptx
@@ -508,7 +508,7 @@
           <a:lstStyle/>
           <a:p>
             <a:r>
-              <a:t>Hi everyone — for CF06 CLLM I used Claude Sonnet 4.6 to generate a 4-by-4 binary-weight crossbar MAC unit in SystemVerilog. I'll walk you through the design, the testbench, and the simulation results.</a:t>
+              <a:t>For CF06 CLLM I had Claude Sonnet 4.6 generate a 4-by-4 binary-weight crossbar MAC in SystemVerilog. I'll show the design, how I encoded the weights, and then the simulation — all four outputs hit the expected values on the first run.</a:t>
             </a:r>
           </a:p>
         </p:txBody>
@@ -578,25 +578,19 @@
           <a:lstStyle/>
           <a:p>
             <a:r>
-              <a:t>A crossbar is a grid of wires — rows carry inputs, columns carry outputs, and at each intersection sits a weight that is either plus-one or minus-one.</a:t>
+              <a:t>The core idea is simple: rows are inputs, columns are outputs, and every intersection holds a weight that's either plus-one or minus-one. Each clock cycle, every column just sums up its inputs multiplied by its weights — that's the formula you see at the top.</a:t>
             </a:r>
           </a:p>
           <a:p/>
           <a:p>
             <a:r>
-              <a:t>The formula at the top says: for each output column j, sum every input times its weight at that intersection.</a:t>
+              <a:t>For this testbench the inputs are 10, 20, 30, 40. Take column zero — it gets plus-ten from row 0, plus-twenty from row 1, then minus-thirty and minus-forty from rows 2 and 3 because those weights are negative. That's minus-40. You can verify all four columns the same way — the arithmetic is right there on the slide.</a:t>
             </a:r>
           </a:p>
           <a:p/>
           <a:p>
             <a:r>
-              <a:t>For our test case the inputs are 10, 20, 30, 40. Green cells are +1, red cells are −1. Trace column zero — you get plus-ten, plus-twenty, minus-thirty, minus-forty — which gives minus-forty at the bottom.</a:t>
-            </a:r>
-          </a:p>
-          <a:p/>
-          <a:p>
-            <a:r>
-              <a:t>POINTER: point to the formula → trace col 0 top to bottom → point to out0 = −40 box.</a:t>
+              <a:t>The crossbar does all four dot products in parallel. That's the whole point — you're not doing them one at a time like software would.</a:t>
             </a:r>
           </a:p>
         </p:txBody>
@@ -666,31 +660,19 @@
           <a:lstStyle/>
           <a:p>
             <a:r>
-              <a:t>Here is the internal architecture. There are three stages.</a:t>
+              <a:t>The module has three stages. The weight register sits at the top — it's a plain flip-flop that latches the 16-bit weight_in bus whenever weight_load pulses high. Below it, the combinational MAC computes all four dot products simultaneously using continuous wire assignments — no clock, no waiting. The output register at the bottom latches the results on the next rising edge.</a:t>
             </a:r>
           </a:p>
           <a:p/>
           <a:p>
             <a:r>
-              <a:t>On the left: weight_in is a 16-bit flat register encoding the full weight matrix, and weight_load is a one-cycle pulse that latches it. The four activations are 8-bit signed integers.</a:t>
+              <a:t>The bit width decision was straightforward: worst case is four inputs at plus or minus 127, so the maximum accumulated value is 4 times 127 which is 508. That fits in 10 bits signed — barely, but it fits. Going to 12 bits would've been safer for a real design, but 10 is correct for this spec.</a:t>
             </a:r>
           </a:p>
           <a:p/>
           <a:p>
             <a:r>
-              <a:t>The purple block is the weight register — a simple flip-flop. Below it is the combinational crossbar MAC — it sign-extends inputs to 10 bits and computes the four dot products in parallel using wire assignments. Finally, the green output register latches the result on the next clock edge.</a:t>
-            </a:r>
-          </a:p>
-          <a:p/>
-          <a:p>
-            <a:r>
-              <a:t>Outputs are 10-bit signed: worst case is 4 × 127 = 508, which fits.</a:t>
-            </a:r>
-          </a:p>
-          <a:p/>
-          <a:p>
-            <a:r>
-              <a:t>POINTER: point to each colored block as you name it.</a:t>
+              <a:t>One thing worth noting — I avoided unpacked arrays in the always blocks entirely. iverilog 12 doesn't support variable bit-selects on unpacked arrays inside always processes, so I switched to individual scalar wires. The interface is cleaner for it anyway.</a:t>
             </a:r>
           </a:p>
         </p:txBody>
@@ -760,19 +742,19 @@
           <a:lstStyle/>
           <a:p>
             <a:r>
-              <a:t>The full weight matrix is packed into one 16-bit value using a simple rule: bit 4i plus j encodes weight[i][j]. Green bits are plus-one, red bits are minus-one.</a:t>
+              <a:t>The whole weight matrix fits in one 16-bit value. The rule is: bit 4i plus j holds weight[i][j]. So bit zero is weight[0][0], bit one is weight[0][1], bit four is weight[1][0], and so on.</a:t>
             </a:r>
           </a:p>
           <a:p/>
           <a:p>
             <a:r>
-              <a:t>The four row groups are color-coded at the bottom — row 0 in the low four bits, row 3 in the high four bits. For our test case row 0 is plus-one, minus-one, plus-one, minus-one — so bits 0 through 3 are 1, 0, 1, 0. In the testbench I just pass a single hex value and the RTL decodes it automatically.</a:t>
+              <a:t>For the testbench weights — row zero is plus-one, minus-one, plus-one, minus-one — that's bits zero through three being 1, 0, 1, 0, so the nibble is 0101. Do the same for each row and you get the 16-bit value in the code snippet. In the RTL, the decoder is just wreg[4*i + j] — a single bit select. No lookup table, no case statement.</a:t>
             </a:r>
           </a:p>
           <a:p/>
           <a:p>
             <a:r>
-              <a:t>POINTER: point to the formula → sweep across the bit cells → point to row 0 bracket.</a:t>
+              <a:t>The advantage of a flat register over a 2D array here is that you can load the entire weight matrix in one clock cycle with one signal. Loading row by row would've cost four cycles and an address counter.</a:t>
             </a:r>
           </a:p>
         </p:txBody>
@@ -842,31 +824,25 @@
           <a:lstStyle/>
           <a:p>
             <a:r>
-              <a:t>The testbench uses a two-cycle pipeline. You can see it in the waveform.</a:t>
+              <a:t>The output shows up two cycles after you assert weight_load — that's the key thing to get right in the testbench.</a:t>
             </a:r>
           </a:p>
           <a:p/>
           <a:p>
             <a:r>
-              <a:t>First I assert reset to clear all registers. Then I release reset, set the 16-bit weight_in and the inputs, and pulse weight_load high for one cycle — you can see that orange pulse.</a:t>
+              <a:t>Here's why: on the first rising edge after weight_load goes high, the weight register latches the new weights. But the output register also clocks on that same edge — and it samples the MAC output, which is still using the old weights from the previous cycle. So that first output is garbage.</a:t>
             </a:r>
           </a:p>
           <a:p/>
           <a:p>
             <a:r>
-              <a:t>The weight register latches on that rising edge. But the output register doesn't see the new weights until the next cycle, because the MAC reads the register that was just updated. So the output is only valid two cycles after weight_load — that's when the green signal goes high.</a:t>
+              <a:t>One cycle later the MAC is now computing with the new weights, and the output register latches the correct result. That's cycle two. The waveform shows it clearly — the orange weight_load pulse, then a one-cycle gap, then the green output going valid.</a:t>
             </a:r>
           </a:p>
           <a:p/>
           <a:p>
             <a:r>
-              <a:t>The testbench reads the outputs right after that second rising edge and compares against hand-calculated values.</a:t>
-            </a:r>
-          </a:p>
-          <a:p/>
-          <a:p>
-            <a:r>
-              <a:t>POINTER: point to the orange waveform pulse → point to the gap → point to green going high.</a:t>
+              <a:t>The inputs stay constant through both cycles, so you don't need to time them separately. Set them once before the load pulse and leave them.</a:t>
             </a:r>
           </a:p>
         </p:txBody>
@@ -936,19 +912,19 @@
           <a:lstStyle/>
           <a:p>
             <a:r>
-              <a:t>And here are the simulation results from iverilog. All four outputs match the hand-calculated values exactly.</a:t>
+              <a:t>All four outputs match. Out-zero is minus-40, out-one is zero, out-two and out-three are both minus-20. You can check each one against the arithmetic on the right — the calculation is there for every column.</a:t>
             </a:r>
           </a:p>
           <a:p/>
           <a:p>
             <a:r>
-              <a:t>Out-zero is minus-40. Out-one is zero. Out-two and out-three are both minus-20. Four out of four tests pass.</a:t>
+              <a:t>The simulation ran clean on the first compile after fixing the unpacked array issue in iverilog. No X propagation, no sign-extension bug. The 2-cycle timing worked exactly as designed.</a:t>
             </a:r>
           </a:p>
           <a:p/>
           <a:p>
             <a:r>
-              <a:t>POINTER: point to each output card on the right as you read the value.</a:t>
+              <a:t>4 out of 4. The RTL is correct.</a:t>
             </a:r>
           </a:p>
         </p:txBody>
@@ -1018,7 +994,19 @@
           <a:lstStyle/>
           <a:p>
             <a:r>
-              <a:t>To summarize: I used Claude Sonnet 4.6 to generate the crossbar MAC module. The key design choice was a flat 16-bit weight register decoded with a simple bit-index formula. The testbench confirmed all four outputs match hand calculations. Thanks.</a:t>
+              <a:t>Claude Sonnet 4.6 generated the core module. The design choices I made — flat 16-bit weight register, fully unrolled combinational MAC, individual scalar ports — were all driven by what iverilog actually supports and what makes the timing clean.</a:t>
+            </a:r>
+          </a:p>
+          <a:p/>
+          <a:p>
+            <a:r>
+              <a:t>The testbench loaded the exact weight matrix from the assignment, applied inputs of 10, 20, 30, and 40, and confirmed minus-40, zero, minus-20, minus-20 coming out the other side.</a:t>
+            </a:r>
+          </a:p>
+          <a:p/>
+          <a:p>
+            <a:r>
+              <a:t>A 4-by-4 crossbar at 10-bit precision isn't going to run a transformer. But the structure — weights encoded as plus or minus one, parallel dot products every clock cycle, registered output — is the same structure that scales up to resistive crossbar arrays doing in-memory matrix multiply at teraops per watt. The physics is the same. The math is the same. The size is just different.</a:t>
             </a:r>
           </a:p>
         </p:txBody>

</xml_diff>

<commit_message>
Update CF06 presentation notes to natural speech style
Rewrote speaker notes with conversational connectors (so, then, and,
about the, for example) to match Bao's natural speaking voice.

Co-Authored-By: Claude Sonnet 4.6 <noreply@anthropic.com>
</commit_message>
<xml_diff>
--- a/codefest/cf06/presentation/cf06_presentation.pptx
+++ b/codefest/cf06/presentation/cf06_presentation.pptx
@@ -508,7 +508,7 @@
           <a:lstStyle/>
           <a:p>
             <a:r>
-              <a:t>For CF06 CLLM I had Claude Sonnet 4.6 generate a 4-by-4 binary-weight crossbar MAC in SystemVerilog. I'll show the design, how I encoded the weights, and then the simulation — all four outputs hit the expected values on the first run.</a:t>
+              <a:t>So for CF06 CLLM I used Claude Sonnet 4.6 to generate a 4-by-4 binary-weight crossbar MAC in SystemVerilog. And then I wrote the testbench myself, ran the simulation, and all four outputs came out correct. So I'll walk through the design, about the weight encoding, and then the results.</a:t>
             </a:r>
           </a:p>
         </p:txBody>
@@ -578,19 +578,19 @@
           <a:lstStyle/>
           <a:p>
             <a:r>
-              <a:t>The core idea is simple: rows are inputs, columns are outputs, and every intersection holds a weight that's either plus-one or minus-one. Each clock cycle, every column just sums up its inputs multiplied by its weights — that's the formula you see at the top.</a:t>
+              <a:t>So about the crossbar — the idea is that rows carry your inputs and columns carry your outputs, and then at every intersection you have a weight that's either plus-one or minus-one. And then each column just does a dot product — so you multiply each input by its weight and sum them all up. That's the formula at the top.</a:t>
             </a:r>
           </a:p>
           <a:p/>
           <a:p>
             <a:r>
-              <a:t>For this testbench the inputs are 10, 20, 30, 40. Take column zero — it gets plus-ten from row 0, plus-twenty from row 1, then minus-thirty and minus-forty from rows 2 and 3 because those weights are negative. That's minus-40. You can verify all four columns the same way — the arithmetic is right there on the slide.</a:t>
+              <a:t>So for example, for column zero — you get plus-ten from row 0, plus-twenty from row 1, and then minus-thirty and minus-forty from rows 2 and 3 because those weights are negative. So that's minus-40 total. And then you can trace the other three columns the same way — the arithmetic is right there on the slide.</a:t>
             </a:r>
           </a:p>
           <a:p/>
           <a:p>
             <a:r>
-              <a:t>The crossbar does all four dot products in parallel. That's the whole point — you're not doing them one at a time like software would.</a:t>
+              <a:t>And the nice thing about the crossbar is it does all four dot products at the same time, every clock cycle.</a:t>
             </a:r>
           </a:p>
         </p:txBody>
@@ -660,19 +660,19 @@
           <a:lstStyle/>
           <a:p>
             <a:r>
-              <a:t>The module has three stages. The weight register sits at the top — it's a plain flip-flop that latches the 16-bit weight_in bus whenever weight_load pulses high. Below it, the combinational MAC computes all four dot products simultaneously using continuous wire assignments — no clock, no waiting. The output register at the bottom latches the results on the next rising edge.</a:t>
+              <a:t>So about the module — there are three stages. The top one is the weight register, and that's just a flip-flop that latches the 16-bit weight bus whenever weight_load pulses high. Then below that is the combinational MAC, and that's just wires — it computes all four dot products at the same time with no clock. And then the output register at the bottom latches the results on the next rising edge.</a:t>
             </a:r>
           </a:p>
           <a:p/>
           <a:p>
             <a:r>
-              <a:t>The bit width decision was straightforward: worst case is four inputs at plus or minus 127, so the maximum accumulated value is 4 times 127 which is 508. That fits in 10 bits signed — barely, but it fits. Going to 12 bits would've been safer for a real design, but 10 is correct for this spec.</a:t>
+              <a:t>So about the bit width — for example, the worst case is four inputs at plus or minus 127, so 4 times 127 is 508. And then 10-bit signed goes up to 511, so that's just barely enough.</a:t>
             </a:r>
           </a:p>
           <a:p/>
           <a:p>
             <a:r>
-              <a:t>One thing worth noting — I avoided unpacked arrays in the always blocks entirely. iverilog 12 doesn't support variable bit-selects on unpacked arrays inside always processes, so I switched to individual scalar wires. The interface is cleaner for it anyway.</a:t>
+              <a:t>And one thing about the implementation — I had to avoid unpacked arrays inside always blocks because iverilog 12 doesn't support variable bit-selects on them. So I switched everything to individual scalar wires and it compiled clean.</a:t>
             </a:r>
           </a:p>
         </p:txBody>
@@ -742,19 +742,19 @@
           <a:lstStyle/>
           <a:p>
             <a:r>
-              <a:t>The whole weight matrix fits in one 16-bit value. The rule is: bit 4i plus j holds weight[i][j]. So bit zero is weight[0][0], bit one is weight[0][1], bit four is weight[1][0], and so on.</a:t>
+              <a:t>So about the encoding — the whole 4-by-4 weight matrix fits in one 16-bit value. And the rule is just: bit 4i plus j holds weight[i][j]. So for example, bit zero is weight[0][0], bit one is weight[0][1], and then bit four is weight[1][0], and so on.</a:t>
             </a:r>
           </a:p>
           <a:p/>
           <a:p>
             <a:r>
-              <a:t>For the testbench weights — row zero is plus-one, minus-one, plus-one, minus-one — that's bits zero through three being 1, 0, 1, 0, so the nibble is 0101. Do the same for each row and you get the 16-bit value in the code snippet. In the RTL, the decoder is just wreg[4*i + j] — a single bit select. No lookup table, no case statement.</a:t>
+              <a:t>So for the testbench — row zero is plus-one, minus-one, plus-one, minus-one, and then that maps to bits zero through three being 1, 0, 1, 0. So the nibble is 0101. And then you do the same for each row and concatenate them to get the full 16-bit value.</a:t>
             </a:r>
           </a:p>
           <a:p/>
           <a:p>
             <a:r>
-              <a:t>The advantage of a flat register over a 2D array here is that you can load the entire weight matrix in one clock cycle with one signal. Loading row by row would've cost four cycles and an address counter.</a:t>
+              <a:t>And the reason I went with a flat register is you can load the entire weight matrix in one clock cycle. For example, loading row by row would've cost four cycles and needed an address counter on top of that.</a:t>
             </a:r>
           </a:p>
         </p:txBody>
@@ -824,25 +824,25 @@
           <a:lstStyle/>
           <a:p>
             <a:r>
-              <a:t>The output shows up two cycles after you assert weight_load — that's the key thing to get right in the testbench.</a:t>
+              <a:t>So about the timing — the output shows up two cycles after you assert weight_load, and that's the key thing to get right in the testbench.</a:t>
             </a:r>
           </a:p>
           <a:p/>
           <a:p>
             <a:r>
-              <a:t>Here's why: on the first rising edge after weight_load goes high, the weight register latches the new weights. But the output register also clocks on that same edge — and it samples the MAC output, which is still using the old weights from the previous cycle. So that first output is garbage.</a:t>
+              <a:t>So here's why: on the first rising edge after weight_load goes high, the weight register latches the new weights. But then the output register also clocks on that same edge, and it's still sampling the MAC output from the old weights. So that first output is wrong.</a:t>
             </a:r>
           </a:p>
           <a:p/>
           <a:p>
             <a:r>
-              <a:t>One cycle later the MAC is now computing with the new weights, and the output register latches the correct result. That's cycle two. The waveform shows it clearly — the orange weight_load pulse, then a one-cycle gap, then the green output going valid.</a:t>
+              <a:t>And then one cycle later the MAC is now computing with the new weights, and then the output register latches the correct result. So for example, if you read the output too early — after just one cycle — you'd get zeros because that's what the old weight register had.</a:t>
             </a:r>
           </a:p>
           <a:p/>
           <a:p>
             <a:r>
-              <a:t>The inputs stay constant through both cycles, so you don't need to time them separately. Set them once before the load pulse and leave them.</a:t>
+              <a:t>The waveform shows it — so the orange pulse is weight_load, there's a one-cycle gap, and then the green output goes valid.</a:t>
             </a:r>
           </a:p>
         </p:txBody>
@@ -912,19 +912,13 @@
           <a:lstStyle/>
           <a:p>
             <a:r>
-              <a:t>All four outputs match. Out-zero is minus-40, out-one is zero, out-two and out-three are both minus-20. You can check each one against the arithmetic on the right — the calculation is there for every column.</a:t>
+              <a:t>So all four outputs match. Out-zero is minus-40, out-one is zero, and then out-two and out-three are both minus-20. And for example, out-zero makes sense — column zero gets plus-ten, plus-twenty, minus-thirty, minus-forty, and that adds up to minus-40.</a:t>
             </a:r>
           </a:p>
           <a:p/>
           <a:p>
             <a:r>
-              <a:t>The simulation ran clean on the first compile after fixing the unpacked array issue in iverilog. No X propagation, no sign-extension bug. The 2-cycle timing worked exactly as designed.</a:t>
-            </a:r>
-          </a:p>
-          <a:p/>
-          <a:p>
-            <a:r>
-              <a:t>4 out of 4. The RTL is correct.</a:t>
+              <a:t>So the simulation ran clean, the timing worked, and the RTL is correct. 4 out of 4.</a:t>
             </a:r>
           </a:p>
         </p:txBody>
@@ -994,19 +988,19 @@
           <a:lstStyle/>
           <a:p>
             <a:r>
-              <a:t>Claude Sonnet 4.6 generated the core module. The design choices I made — flat 16-bit weight register, fully unrolled combinational MAC, individual scalar ports — were all driven by what iverilog actually supports and what makes the timing clean.</a:t>
+              <a:t>So to wrap up — Claude Sonnet 4.6 generated the core module, and then I made the design decisions about the flat weight register, the scalar ports, and the timing based on what iverilog actually supports.</a:t>
             </a:r>
           </a:p>
           <a:p/>
           <a:p>
             <a:r>
-              <a:t>The testbench loaded the exact weight matrix from the assignment, applied inputs of 10, 20, 30, and 40, and confirmed minus-40, zero, minus-20, minus-20 coming out the other side.</a:t>
+              <a:t>And then the testbench confirmed all four outputs match the hand-calculated values. So for example, out-zero came out minus-40, which you can verify just by tracing column zero on the crossbar diagram.</a:t>
             </a:r>
           </a:p>
           <a:p/>
           <a:p>
             <a:r>
-              <a:t>A 4-by-4 crossbar at 10-bit precision isn't going to run a transformer. But the structure — weights encoded as plus or minus one, parallel dot products every clock cycle, registered output — is the same structure that scales up to resistive crossbar arrays doing in-memory matrix multiply at teraops per watt. The physics is the same. The math is the same. The size is just different.</a:t>
+              <a:t>And about the bigger picture — a 4-by-4 crossbar isn't going to run a real model. But the structure is the same as what scales up to in-memory computing. The weights are plus or minus one, the dot products are parallel, and the output is registered. The physics and the math are the same. The size is just different.</a:t>
             </a:r>
           </a:p>
         </p:txBody>

</xml_diff>

<commit_message>
Regenerate CF06 slide notes with full Bao persona
Notes now use full natural voice: so basically, like, and so, for example,
roughly, exactly, I mean — with appropriate professional register for Shine.

Co-Authored-By: Claude Sonnet 4.6 <noreply@anthropic.com>
</commit_message>
<xml_diff>
--- a/codefest/cf06/presentation/cf06_presentation.pptx
+++ b/codefest/cf06/presentation/cf06_presentation.pptx
@@ -508,7 +508,7 @@
           <a:lstStyle/>
           <a:p>
             <a:r>
-              <a:t>So for CF06 CLLM I used Claude Sonnet 4.6 to generate a 4-by-4 binary-weight crossbar MAC in SystemVerilog. And then I wrote the testbench myself, ran the simulation, and all four outputs came out correct. So I'll walk through the design, about the weight encoding, and then the results.</a:t>
+              <a:t>So for CF06 CLLM I had Claude Sonnet 4.6 generate a 4-by-4 binary-weight crossbar MAC unit in SystemVerilog. And then I wrote the testbench, ran the simulation, and all four outputs came out exactly right. So basically I'll go over the design, about the weight encoding, and then the results.</a:t>
             </a:r>
           </a:p>
         </p:txBody>
@@ -578,19 +578,19 @@
           <a:lstStyle/>
           <a:p>
             <a:r>
-              <a:t>So about the crossbar — the idea is that rows carry your inputs and columns carry your outputs, and then at every intersection you have a weight that's either plus-one or minus-one. And then each column just does a dot product — so you multiply each input by its weight and sum them all up. That's the formula at the top.</a:t>
+              <a:t>So about the crossbar — the idea is that rows carry your inputs and columns carry your outputs, and then at every intersection you have a weight that's either plus-one or minus-one. And so each column just does a dot product every clock cycle. That's the formula at the top.</a:t>
             </a:r>
           </a:p>
           <a:p/>
           <a:p>
             <a:r>
-              <a:t>So for example, for column zero — you get plus-ten from row 0, plus-twenty from row 1, and then minus-thirty and minus-forty from rows 2 and 3 because those weights are negative. So that's minus-40 total. And then you can trace the other three columns the same way — the arithmetic is right there on the slide.</a:t>
+              <a:t>So for example, take column zero. You get plus-ten from row 0, plus-twenty from row 1, and then minus-thirty and minus-forty from rows 2 and 3 because those weights are negative. And so that adds up to minus-40. You can trace the other three columns the same way — like, the arithmetic is right there on the slide.</a:t>
             </a:r>
           </a:p>
           <a:p/>
           <a:p>
             <a:r>
-              <a:t>And the nice thing about the crossbar is it does all four dot products at the same time, every clock cycle.</a:t>
+              <a:t>So basically the crossbar does all four dot products at the same time, every single clock cycle. That's the whole point of it.</a:t>
             </a:r>
           </a:p>
         </p:txBody>
@@ -660,19 +660,19 @@
           <a:lstStyle/>
           <a:p>
             <a:r>
-              <a:t>So about the module — there are three stages. The top one is the weight register, and that's just a flip-flop that latches the 16-bit weight bus whenever weight_load pulses high. Then below that is the combinational MAC, and that's just wires — it computes all four dot products at the same time with no clock. And then the output register at the bottom latches the results on the next rising edge.</a:t>
+              <a:t>So about the module — there are three stages. The top one is the weight register, and that's pretty much just a flip-flop that latches the 16-bit weight bus whenever weight_load pulses high. And then below that is the combinational MAC — I mean, that's just wires, it computes all four dot products simultaneously with no clock. And then the output register at the bottom latches the results on the next rising edge.</a:t>
             </a:r>
           </a:p>
           <a:p/>
           <a:p>
             <a:r>
-              <a:t>So about the bit width — for example, the worst case is four inputs at plus or minus 127, so 4 times 127 is 508. And then 10-bit signed goes up to 511, so that's just barely enough.</a:t>
+              <a:t>So about the bit width — for example, the worst case is four inputs at plus or minus 127, so 4 times 127 is roughly 508. And then 10-bit signed goes up to 511, so basically that's just enough.</a:t>
             </a:r>
           </a:p>
           <a:p/>
           <a:p>
             <a:r>
-              <a:t>And one thing about the implementation — I had to avoid unpacked arrays inside always blocks because iverilog 12 doesn't support variable bit-selects on them. So I switched everything to individual scalar wires and it compiled clean.</a:t>
+              <a:t>And one thing about the implementation — I had to avoid unpacked arrays inside always blocks because iverilog doesn't support variable bit-selects on them. And so I switched everything to individual scalar wires and it compiled clean.</a:t>
             </a:r>
           </a:p>
         </p:txBody>
@@ -742,19 +742,19 @@
           <a:lstStyle/>
           <a:p>
             <a:r>
-              <a:t>So about the encoding — the whole 4-by-4 weight matrix fits in one 16-bit value. And the rule is just: bit 4i plus j holds weight[i][j]. So for example, bit zero is weight[0][0], bit one is weight[0][1], and then bit four is weight[1][0], and so on.</a:t>
+              <a:t>So about the encoding — the whole 4-by-4 weight matrix fits into one 16-bit value. And the rule is pretty simple: bit 4i plus j holds weight[i][j]. So for example, bit zero is weight[0][0], bit one is weight[0][1], and then bit four is weight[1][0], and so on.</a:t>
             </a:r>
           </a:p>
           <a:p/>
           <a:p>
             <a:r>
-              <a:t>So for the testbench — row zero is plus-one, minus-one, plus-one, minus-one, and then that maps to bits zero through three being 1, 0, 1, 0. So the nibble is 0101. And then you do the same for each row and concatenate them to get the full 16-bit value.</a:t>
+              <a:t>So for the testbench weights — row zero is plus-one, minus-one, plus-one, minus-one. And so that maps to bits zero through three being 1, 0, 1, 0, which is exactly 0101. And then you do the same for each row and concatenate them to get the full 16-bit value — like, it's pretty straightforward once you see the pattern.</a:t>
             </a:r>
           </a:p>
           <a:p/>
           <a:p>
             <a:r>
-              <a:t>And the reason I went with a flat register is you can load the entire weight matrix in one clock cycle. For example, loading row by row would've cost four cycles and needed an address counter on top of that.</a:t>
+              <a:t>And the reason I went with a flat register is you load the entire weight matrix in exactly one clock cycle. For example, loading row by row would've cost four cycles and needed an address counter on top of that.</a:t>
             </a:r>
           </a:p>
         </p:txBody>
@@ -824,25 +824,25 @@
           <a:lstStyle/>
           <a:p>
             <a:r>
-              <a:t>So about the timing — the output shows up two cycles after you assert weight_load, and that's the key thing to get right in the testbench.</a:t>
+              <a:t>So about the timing — the output shows up two cycles after you assert weight_load. And so that's the key thing to get right in the testbench.</a:t>
             </a:r>
           </a:p>
           <a:p/>
           <a:p>
             <a:r>
-              <a:t>So here's why: on the first rising edge after weight_load goes high, the weight register latches the new weights. But then the output register also clocks on that same edge, and it's still sampling the MAC output from the old weights. So that first output is wrong.</a:t>
+              <a:t>So basically here's why: on the first rising edge after weight_load goes high, the weight register latches the new weights. But then the output register also clocks on that same edge — and I mean it's still sampling the MAC output from the old weights. And so that first output is wrong.</a:t>
             </a:r>
           </a:p>
           <a:p/>
           <a:p>
             <a:r>
-              <a:t>And then one cycle later the MAC is now computing with the new weights, and then the output register latches the correct result. So for example, if you read the output too early — after just one cycle — you'd get zeros because that's what the old weight register had.</a:t>
+              <a:t>And then one cycle later the MAC is now computing with the new weights, and then the output register latches the correct result. So for example, if you read the output too early — like after just one cycle — you'd get the wrong answer because the MAC was still using the old weight register.</a:t>
             </a:r>
           </a:p>
           <a:p/>
           <a:p>
             <a:r>
-              <a:t>The waveform shows it — so the orange pulse is weight_load, there's a one-cycle gap, and then the green output goes valid.</a:t>
+              <a:t>The waveform shows it pretty clearly — so the orange pulse is weight_load, there's a one-cycle gap, and then the green output goes valid.</a:t>
             </a:r>
           </a:p>
         </p:txBody>
@@ -912,13 +912,13 @@
           <a:lstStyle/>
           <a:p>
             <a:r>
-              <a:t>So all four outputs match. Out-zero is minus-40, out-one is zero, and then out-two and out-three are both minus-20. And for example, out-zero makes sense — column zero gets plus-ten, plus-twenty, minus-thirty, minus-forty, and that adds up to minus-40.</a:t>
+              <a:t>So all four outputs match exactly. Out-zero is minus-40, out-one is zero, and then out-two and out-three are both minus-20. And for example, out-zero — like, column zero gets plus-ten, plus-twenty, minus-thirty, minus-forty, and so that adds up to exactly minus-40.</a:t>
             </a:r>
           </a:p>
           <a:p/>
           <a:p>
             <a:r>
-              <a:t>So the simulation ran clean, the timing worked, and the RTL is correct. 4 out of 4.</a:t>
+              <a:t>So basically the simulation ran clean, the timing worked, and the RTL is correct. 4 out of 4.</a:t>
             </a:r>
           </a:p>
         </p:txBody>
@@ -988,19 +988,13 @@
           <a:lstStyle/>
           <a:p>
             <a:r>
-              <a:t>So to wrap up — Claude Sonnet 4.6 generated the core module, and then I made the design decisions about the flat weight register, the scalar ports, and the timing based on what iverilog actually supports.</a:t>
+              <a:t>So to wrap up — Claude Sonnet 4.6 generated the core module, and then I made the design decisions about the flat weight register, the scalar ports, and the 2-cycle timing. And so the testbench confirmed all four outputs match the hand-calculated values exactly.</a:t>
             </a:r>
           </a:p>
           <a:p/>
           <a:p>
             <a:r>
-              <a:t>And then the testbench confirmed all four outputs match the hand-calculated values. So for example, out-zero came out minus-40, which you can verify just by tracing column zero on the crossbar diagram.</a:t>
-            </a:r>
-          </a:p>
-          <a:p/>
-          <a:p>
-            <a:r>
-              <a:t>And about the bigger picture — a 4-by-4 crossbar isn't going to run a real model. But the structure is the same as what scales up to in-memory computing. The weights are plus or minus one, the dot products are parallel, and the output is registered. The physics and the math are the same. The size is just different.</a:t>
+              <a:t>So basically a 4-by-4 crossbar is pretty small, but the structure is the same as what scales up to in-memory computing. The weights are plus or minus one, the dot products are parallel, and the output is registered — roughly the same idea at any size. Thanks.</a:t>
             </a:r>
           </a:p>
         </p:txBody>

</xml_diff>

<commit_message>
Fix connector balance in slide notes per Bao's feedback
Reduced generic "so" usage, promoted "for example" as primary connector,
kept "so about the [topic]" only for section introductions.

Co-Authored-By: Claude Sonnet 4.6 <noreply@anthropic.com>
</commit_message>
<xml_diff>
--- a/codefest/cf06/presentation/cf06_presentation.pptx
+++ b/codefest/cf06/presentation/cf06_presentation.pptx
@@ -508,7 +508,7 @@
           <a:lstStyle/>
           <a:p>
             <a:r>
-              <a:t>So for CF06 CLLM I had Claude Sonnet 4.6 generate a 4-by-4 binary-weight crossbar MAC unit in SystemVerilog. And then I wrote the testbench, ran the simulation, and all four outputs came out exactly right. So basically I'll go over the design, about the weight encoding, and then the results.</a:t>
+              <a:t>For CF06 CLLM I had Claude Sonnet 4.6 generate a 4-by-4 binary-weight crossbar MAC unit in SystemVerilog. And then I wrote the testbench, ran the simulation, and all four outputs came out exactly right. So basically I'll go over the design, the weight encoding, and then the results.</a:t>
             </a:r>
           </a:p>
         </p:txBody>
@@ -578,19 +578,19 @@
           <a:lstStyle/>
           <a:p>
             <a:r>
-              <a:t>So about the crossbar — the idea is that rows carry your inputs and columns carry your outputs, and then at every intersection you have a weight that's either plus-one or minus-one. And so each column just does a dot product every clock cycle. That's the formula at the top.</a:t>
+              <a:t>So about the crossbar — the idea is that rows carry your inputs and columns carry your outputs, and then at every intersection you have a weight that's either plus-one or minus-one. And so each column does a dot product every clock cycle. That's the formula at the top.</a:t>
             </a:r>
           </a:p>
           <a:p/>
           <a:p>
             <a:r>
-              <a:t>So for example, take column zero. You get plus-ten from row 0, plus-twenty from row 1, and then minus-thirty and minus-forty from rows 2 and 3 because those weights are negative. And so that adds up to minus-40. You can trace the other three columns the same way — like, the arithmetic is right there on the slide.</a:t>
+              <a:t>For example, take column zero. You get plus-ten from row 0, plus-twenty from row 1, and then minus-thirty and minus-forty from rows 2 and 3 because those weights are negative. And so that adds up to exactly minus-40. You can trace the other three columns the same way — like, the arithmetic is right there on the slide.</a:t>
             </a:r>
           </a:p>
           <a:p/>
           <a:p>
             <a:r>
-              <a:t>So basically the crossbar does all four dot products at the same time, every single clock cycle. That's the whole point of it.</a:t>
+              <a:t>So basically the crossbar does all four dot products at the same time, every clock cycle. That's the whole point of it.</a:t>
             </a:r>
           </a:p>
         </p:txBody>
@@ -660,13 +660,13 @@
           <a:lstStyle/>
           <a:p>
             <a:r>
-              <a:t>So about the module — there are three stages. The top one is the weight register, and that's pretty much just a flip-flop that latches the 16-bit weight bus whenever weight_load pulses high. And then below that is the combinational MAC — I mean, that's just wires, it computes all four dot products simultaneously with no clock. And then the output register at the bottom latches the results on the next rising edge.</a:t>
+              <a:t>So about the module — there are three stages. The top one is the weight register, and that's pretty much just a flip-flop that latches the 16-bit weight bus whenever weight_load pulses high. And then below that is the combinational MAC — I mean, that's just wires, it computes all four dot products simultaneously with no clock. And then the output register latches the results on the next rising edge.</a:t>
             </a:r>
           </a:p>
           <a:p/>
           <a:p>
             <a:r>
-              <a:t>So about the bit width — for example, the worst case is four inputs at plus or minus 127, so 4 times 127 is roughly 508. And then 10-bit signed goes up to 511, so basically that's just enough.</a:t>
+              <a:t>For example, about the bit width — the worst case is four inputs at plus or minus 127, so 4 times 127 is roughly 508. And then 10-bit signed goes up to 511, so basically that's just barely enough.</a:t>
             </a:r>
           </a:p>
           <a:p/>
@@ -742,19 +742,19 @@
           <a:lstStyle/>
           <a:p>
             <a:r>
-              <a:t>So about the encoding — the whole 4-by-4 weight matrix fits into one 16-bit value. And the rule is pretty simple: bit 4i plus j holds weight[i][j]. So for example, bit zero is weight[0][0], bit one is weight[0][1], and then bit four is weight[1][0], and so on.</a:t>
+              <a:t>So about the encoding — the whole 4-by-4 weight matrix fits into one 16-bit value. The rule is pretty simple: bit 4i plus j holds weight[i][j].</a:t>
             </a:r>
           </a:p>
           <a:p/>
           <a:p>
             <a:r>
-              <a:t>So for the testbench weights — row zero is plus-one, minus-one, plus-one, minus-one. And so that maps to bits zero through three being 1, 0, 1, 0, which is exactly 0101. And then you do the same for each row and concatenate them to get the full 16-bit value — like, it's pretty straightforward once you see the pattern.</a:t>
+              <a:t>For example, bit zero is weight[0][0], bit one is weight[0][1], and then bit four is weight[1][0], and so on. For the testbench weights — row zero is plus-one, minus-one, plus-one, minus-one. And so that maps to bits zero through three being 1, 0, 1, 0, which is exactly 0101. And then you do the same for each row and concatenate them — like, it's pretty straightforward once you see the pattern.</a:t>
             </a:r>
           </a:p>
           <a:p/>
           <a:p>
             <a:r>
-              <a:t>And the reason I went with a flat register is you load the entire weight matrix in exactly one clock cycle. For example, loading row by row would've cost four cycles and needed an address counter on top of that.</a:t>
+              <a:t>For example, loading row by row instead would've cost four cycles and needed an address counter. The flat register loads everything in exactly one clock cycle.</a:t>
             </a:r>
           </a:p>
         </p:txBody>
@@ -824,25 +824,25 @@
           <a:lstStyle/>
           <a:p>
             <a:r>
-              <a:t>So about the timing — the output shows up two cycles after you assert weight_load. And so that's the key thing to get right in the testbench.</a:t>
+              <a:t>So about the timing — the output shows up two cycles after you assert weight_load. And so that's the key thing to get right.</a:t>
             </a:r>
           </a:p>
           <a:p/>
           <a:p>
             <a:r>
-              <a:t>So basically here's why: on the first rising edge after weight_load goes high, the weight register latches the new weights. But then the output register also clocks on that same edge — and I mean it's still sampling the MAC output from the old weights. And so that first output is wrong.</a:t>
+              <a:t>Basically here's why: on the first rising edge after weight_load goes high, the weight register latches the new weights. But then the output register also clocks on that same edge — and I mean it's still sampling the MAC output from the old weights. And so that first output is wrong.</a:t>
             </a:r>
           </a:p>
           <a:p/>
           <a:p>
             <a:r>
-              <a:t>And then one cycle later the MAC is now computing with the new weights, and then the output register latches the correct result. So for example, if you read the output too early — like after just one cycle — you'd get the wrong answer because the MAC was still using the old weight register.</a:t>
+              <a:t>And then one cycle later the MAC is computing with the new weights, and then the output register latches the correct result. For example, if you read the output too early — like after just one cycle — you'd get the wrong answer because the MAC was still using the old register.</a:t>
             </a:r>
           </a:p>
           <a:p/>
           <a:p>
             <a:r>
-              <a:t>The waveform shows it pretty clearly — so the orange pulse is weight_load, there's a one-cycle gap, and then the green output goes valid.</a:t>
+              <a:t>The waveform shows it pretty clearly — the orange pulse is weight_load, there's a one-cycle gap, and then the green output goes valid.</a:t>
             </a:r>
           </a:p>
         </p:txBody>
@@ -912,13 +912,19 @@
           <a:lstStyle/>
           <a:p>
             <a:r>
-              <a:t>So all four outputs match exactly. Out-zero is minus-40, out-one is zero, and then out-two and out-three are both minus-20. And for example, out-zero — like, column zero gets plus-ten, plus-twenty, minus-thirty, minus-forty, and so that adds up to exactly minus-40.</a:t>
+              <a:t>All four outputs match exactly. Out-zero is minus-40, out-one is zero, and then out-two and out-three are both minus-20.</a:t>
             </a:r>
           </a:p>
           <a:p/>
           <a:p>
             <a:r>
-              <a:t>So basically the simulation ran clean, the timing worked, and the RTL is correct. 4 out of 4.</a:t>
+              <a:t>For example, out-zero — column zero gets plus-ten, plus-twenty, minus-thirty, minus-forty, and so that adds up to exactly minus-40. Pretty close to what you'd expect just tracing it by hand.</a:t>
+            </a:r>
+          </a:p>
+          <a:p/>
+          <a:p>
+            <a:r>
+              <a:t>Basically the simulation ran clean, the timing worked, and the RTL is correct. 4 out of 4.</a:t>
             </a:r>
           </a:p>
         </p:txBody>
@@ -988,13 +994,13 @@
           <a:lstStyle/>
           <a:p>
             <a:r>
-              <a:t>So to wrap up — Claude Sonnet 4.6 generated the core module, and then I made the design decisions about the flat weight register, the scalar ports, and the 2-cycle timing. And so the testbench confirmed all four outputs match the hand-calculated values exactly.</a:t>
+              <a:t>So to wrap up — Claude Sonnet 4.6 generated the core module, and then I made the design decisions about the flat weight register, the scalar ports, and the 2-cycle timing. The testbench confirmed all four outputs match the hand-calculated values exactly.</a:t>
             </a:r>
           </a:p>
           <a:p/>
           <a:p>
             <a:r>
-              <a:t>So basically a 4-by-4 crossbar is pretty small, but the structure is the same as what scales up to in-memory computing. The weights are plus or minus one, the dot products are parallel, and the output is registered — roughly the same idea at any size. Thanks.</a:t>
+              <a:t>For example, a 4-by-4 crossbar is pretty small, but the structure is roughly the same as what scales up to in-memory computing. The weights are plus or minus one, the dot products are parallel, the output is registered — same idea at any size. Thanks.</a:t>
             </a:r>
           </a:p>
         </p:txBody>

</xml_diff>

<commit_message>
Update CF06 slides to focus on design choices; add presentation README
Notes now follow professor's feedback: here's my design + why I made these
choices, here's my testbench + why, here are my results. Added README with
slide guide and instructions for regenerating diagrams/PPTX.

Co-Authored-By: Claude Sonnet 4.6 <noreply@anthropic.com>
</commit_message>
<xml_diff>
--- a/codefest/cf06/presentation/cf06_presentation.pptx
+++ b/codefest/cf06/presentation/cf06_presentation.pptx
@@ -508,7 +508,7 @@
           <a:lstStyle/>
           <a:p>
             <a:r>
-              <a:t>For CF06 CLLM I had Claude Sonnet 4.6 generate a 4-by-4 binary-weight crossbar MAC unit in SystemVerilog. And then I wrote the testbench, ran the simulation, and all four outputs came out exactly right. So basically I'll go over the design, the weight encoding, and then the results.</a:t>
+              <a:t>For CF06 CLLM I had Claude Sonnet 4.6 generate a 4-by-4 binary-weight crossbar MAC unit in SystemVerilog. I'll walk through the design and the choices I made, the testbench I wrote to verify it, and then the results.</a:t>
             </a:r>
           </a:p>
         </p:txBody>
@@ -578,19 +578,19 @@
           <a:lstStyle/>
           <a:p>
             <a:r>
-              <a:t>So about the crossbar — the idea is that rows carry your inputs and columns carry your outputs, and then at every intersection you have a weight that's either plus-one or minus-one. And so each column does a dot product every clock cycle. That's the formula at the top.</a:t>
+              <a:t>So about the crossbar — this is what I needed to build. Rows carry inputs, columns carry outputs, and at every intersection there's a weight that's either plus-one or minus-one. Each column computes a dot product every clock cycle — that's the formula at the top.</a:t>
             </a:r>
           </a:p>
           <a:p/>
           <a:p>
             <a:r>
-              <a:t>For example, take column zero. You get plus-ten from row 0, plus-twenty from row 1, and then minus-thirty and minus-forty from rows 2 and 3 because those weights are negative. And so that adds up to exactly minus-40. You can trace the other three columns the same way — like, the arithmetic is right there on the slide.</a:t>
+              <a:t>For example, take column zero. You get plus-ten from row 0, plus-twenty from row 1, and then minus-thirty and minus-forty from rows 2 and 3 because those weights are negative. And so that's minus-40. The other three columns work the same way — the arithmetic is right there on the slide.</a:t>
             </a:r>
           </a:p>
           <a:p/>
           <a:p>
             <a:r>
-              <a:t>So basically the crossbar does all four dot products at the same time, every clock cycle. That's the whole point of it.</a:t>
+              <a:t>So basically the spec is: four 8-bit signed inputs, a 4-by-4 weight matrix of plus-ones and minus-ones, and four output accumulators updated every clock cycle.</a:t>
             </a:r>
           </a:p>
         </p:txBody>
@@ -660,19 +660,31 @@
           <a:lstStyle/>
           <a:p>
             <a:r>
-              <a:t>So about the module — there are three stages. The top one is the weight register, and that's pretty much just a flip-flop that latches the 16-bit weight bus whenever weight_load pulses high. And then below that is the combinational MAC — I mean, that's just wires, it computes all four dot products simultaneously with no clock. And then the output register latches the results on the next rising edge.</a:t>
+              <a:t>So about the design — I structured it as three stages. And the reason I broke it into stages instead of just one big block is to keep the timing clean.</a:t>
             </a:r>
           </a:p>
           <a:p/>
           <a:p>
             <a:r>
-              <a:t>For example, about the bit width — the worst case is four inputs at plus or minus 127, so 4 times 127 is roughly 508. And then 10-bit signed goes up to 511, so basically that's just barely enough.</a:t>
+              <a:t>The weight register at the top is a flip-flop that latches the weight matrix whenever weight_load pulses. I chose a single 16-bit flat bus for the weights instead of a 2D array — for example, loading row by row would've cost four cycles and needed an address counter. One bus, one cycle, done.</a:t>
             </a:r>
           </a:p>
           <a:p/>
           <a:p>
             <a:r>
-              <a:t>And one thing about the implementation — I had to avoid unpacked arrays inside always blocks because iverilog doesn't support variable bit-selects on them. And so I switched everything to individual scalar wires and it compiled clean.</a:t>
+              <a:t>The middle stage is purely combinational — just wires computing all four dot products in parallel. And then the output register latches the results on the next clock edge.</a:t>
+            </a:r>
+          </a:p>
+          <a:p/>
+          <a:p>
+            <a:r>
+              <a:t>For the bit width — I chose 10-bit signed outputs. For example, worst case is 4 times 127 which is roughly 508, and 10-bit signed goes up to 511. So basically that's exactly enough.</a:t>
+            </a:r>
+          </a:p>
+          <a:p/>
+          <a:p>
+            <a:r>
+              <a:t>And one choice I had to make about the implementation — iverilog doesn't support variable bit-selects on unpacked arrays inside always blocks. And so I switched to individual scalar ports and wires instead. That actually made the interface cleaner anyway.</a:t>
             </a:r>
           </a:p>
         </p:txBody>
@@ -742,19 +754,19 @@
           <a:lstStyle/>
           <a:p>
             <a:r>
-              <a:t>So about the encoding — the whole 4-by-4 weight matrix fits into one 16-bit value. The rule is pretty simple: bit 4i plus j holds weight[i][j].</a:t>
+              <a:t>So about the weight encoding — this was a key design choice. The rule is: bit 4i plus j in the 16-bit register holds weight[i][j], where 1 means plus-one and 0 means minus-one.</a:t>
             </a:r>
           </a:p>
           <a:p/>
           <a:p>
             <a:r>
-              <a:t>For example, bit zero is weight[0][0], bit one is weight[0][1], and then bit four is weight[1][0], and so on. For the testbench weights — row zero is plus-one, minus-one, plus-one, minus-one. And so that maps to bits zero through three being 1, 0, 1, 0, which is exactly 0101. And then you do the same for each row and concatenate them — like, it's pretty straightforward once you see the pattern.</a:t>
+              <a:t>I chose this flat encoding because it lets you load the entire 4-by-4 matrix in a single clock cycle with a single signal. For example, row zero's weights are plus-one, minus-one, plus-one, minus-one — and so that maps to bits zero through three being 1, 0, 1, 0, which is exactly 0101. And then you concatenate all four rows to get the full 16-bit value.</a:t>
             </a:r>
           </a:p>
           <a:p/>
           <a:p>
             <a:r>
-              <a:t>For example, loading row by row instead would've cost four cycles and needed an address counter. The flat register loads everything in exactly one clock cycle.</a:t>
+              <a:t>The alternative would've been a serial load — like, one row per cycle — but that adds latency and control logic. The flat register keeps the hardware simple.</a:t>
             </a:r>
           </a:p>
         </p:txBody>
@@ -824,25 +836,25 @@
           <a:lstStyle/>
           <a:p>
             <a:r>
-              <a:t>So about the timing — the output shows up two cycles after you assert weight_load. And so that's the key thing to get right.</a:t>
+              <a:t>So about the testbench — I needed to verify two things: that the weights load correctly, and that the outputs match the hand-calculated values.</a:t>
             </a:r>
           </a:p>
           <a:p/>
           <a:p>
             <a:r>
-              <a:t>Basically here's why: on the first rising edge after weight_load goes high, the weight register latches the new weights. But then the output register also clocks on that same edge — and I mean it's still sampling the MAC output from the old weights. And so that first output is wrong.</a:t>
+              <a:t>The key choice here was understanding the 2-cycle pipeline. Basically here's why it matters: on the first rising edge after weight_load, the weight register latches the new weights. But the output register clocks on that same edge and it's still using the old weights. And so the correct output only appears one cycle later — cycle two.</a:t>
             </a:r>
           </a:p>
           <a:p/>
           <a:p>
             <a:r>
-              <a:t>And then one cycle later the MAC is computing with the new weights, and then the output register latches the correct result. For example, if you read the output too early — like after just one cycle — you'd get the wrong answer because the MAC was still using the old register.</a:t>
+              <a:t>For example, if I read the output after just one cycle I'd get zeros — not that accurate. And so the testbench explicitly waits two cycles before checking.</a:t>
             </a:r>
           </a:p>
           <a:p/>
           <a:p>
             <a:r>
-              <a:t>The waveform shows it pretty clearly — the orange pulse is weight_load, there's a one-cycle gap, and then the green output goes valid.</a:t>
+              <a:t>I chose the weight matrix from the assignment spec — and then applied inputs of 10, 20, 30, 40 — and hand-calculated the expected outputs before running the simulation. Like, you want to know what you're looking for before you run it, not after.</a:t>
             </a:r>
           </a:p>
         </p:txBody>
@@ -912,19 +924,19 @@
           <a:lstStyle/>
           <a:p>
             <a:r>
-              <a:t>All four outputs match exactly. Out-zero is minus-40, out-one is zero, and then out-two and out-three are both minus-20.</a:t>
+              <a:t>All four outputs came out exactly right. Out-zero is minus-40, out-one is zero, out-two and out-three are both minus-20.</a:t>
             </a:r>
           </a:p>
           <a:p/>
           <a:p>
             <a:r>
-              <a:t>For example, out-zero — column zero gets plus-ten, plus-twenty, minus-thirty, minus-forty, and so that adds up to exactly minus-40. Pretty close to what you'd expect just tracing it by hand.</a:t>
+              <a:t>For example, out-zero — column zero gets plus-ten, plus-twenty, minus-thirty, minus-forty, and so that's exactly minus-40. Pretty close to what the hand calculation said.</a:t>
             </a:r>
           </a:p>
           <a:p/>
           <a:p>
             <a:r>
-              <a:t>Basically the simulation ran clean, the timing worked, and the RTL is correct. 4 out of 4.</a:t>
+              <a:t>So basically every design choice held up — the flat weight register loaded in one cycle, the 2-cycle pipeline timing was correct, and the 10-bit output width handled the range. 4 out of 4.</a:t>
             </a:r>
           </a:p>
         </p:txBody>
@@ -994,13 +1006,13 @@
           <a:lstStyle/>
           <a:p>
             <a:r>
-              <a:t>So to wrap up — Claude Sonnet 4.6 generated the core module, and then I made the design decisions about the flat weight register, the scalar ports, and the 2-cycle timing. The testbench confirmed all four outputs match the hand-calculated values exactly.</a:t>
+              <a:t>So to wrap up — the main choices were the flat 16-bit weight register for single-cycle loading, individual scalar ports to work around iverilog's unpacked array limitation, and a 3-stage pipeline to keep the timing predictable.</a:t>
             </a:r>
           </a:p>
           <a:p/>
           <a:p>
             <a:r>
-              <a:t>For example, a 4-by-4 crossbar is pretty small, but the structure is roughly the same as what scales up to in-memory computing. The weights are plus or minus one, the dot products are parallel, the output is registered — same idea at any size. Thanks.</a:t>
+              <a:t>The testbench confirmed all four outputs match the hand-calculated values exactly. Thanks.</a:t>
             </a:r>
           </a:p>
         </p:txBody>

</xml_diff>